<commit_message>
Deck: clarify L3b vs L4 on harness app
Co-authored-by: Copilot App <223556219+Copilot@users.noreply.github.com>
</commit_message>
<xml_diff>
--- a/deliverables/SDK_QA_Strategy.pptx
+++ b/deliverables/SDK_QA_Strategy.pptx
@@ -4575,7 +4575,7 @@
                 <a:ea typeface="Calibri" pitchFamily="34" charset="-122"/>
                 <a:cs typeface="Calibri" pitchFamily="34" charset="-120"/>
               </a:rPr>
-              <a:t>L3b: rotation, background, kill and relaunch, session restored from secure storage.</a:t>
+              <a:t>L3b: UI tests on the harness app + fake server: rotation, background, kill and relaunch, session restore.</a:t>
             </a:r>
             <a:endParaRPr lang="en-US" sz="1150" dirty="0"/>
           </a:p>
@@ -4596,7 +4596,7 @@
                 <a:ea typeface="Calibri" pitchFamily="34" charset="-122"/>
                 <a:cs typeface="Calibri" pitchFamily="34" charset="-120"/>
               </a:rPr>
-              <a:t>L4: harness app against staging.</a:t>
+              <a:t>L4: same harness app, real staging backend.</a:t>
             </a:r>
             <a:endParaRPr lang="en-US" sz="1150" dirty="0"/>
           </a:p>

</xml_diff>

<commit_message>
Document demo PR 6 (flaky test) in README, deliverable, prompt library and deck
Co-authored-by: Copilot App <223556219+Copilot@users.noreply.github.com>
</commit_message>
<xml_diff>
--- a/deliverables/SDK_QA_Strategy.pptx
+++ b/deliverables/SDK_QA_Strategy.pptx
@@ -861,7 +861,7 @@
           <a:p>
             <a:r>
               <a:rPr lang="en-US" dirty="0"/>
-              <a:t>Open PR #2 live: signature check green, behaviour check red on iOS only. Then PR #5 for the digester message.</a:t>
+              <a:t>Open PR #2 live: signature check green, behaviour check red on iOS only. Then PR #5 for the digester message, and PR #6 for the flaky flag.</a:t>
             </a:r>
             <a:endParaRPr lang="en-US" dirty="0"/>
           </a:p>
@@ -2185,7 +2185,7 @@
                 <a:ea typeface="Cambria" pitchFamily="34" charset="-122"/>
                 <a:cs typeface="Cambria" pitchFamily="34" charset="-120"/>
               </a:rPr>
-              <a:t>5</a:t>
+              <a:t>6</a:t>
             </a:r>
             <a:endParaRPr lang="en-US" sz="3600" dirty="0"/>
           </a:p>
@@ -6102,7 +6102,7 @@
                 <a:ea typeface="Cambria" pitchFamily="34" charset="-122"/>
                 <a:cs typeface="Cambria" pitchFamily="34" charset="-120"/>
               </a:rPr>
-              <a:t>Five demo PRs: which layer catches what</a:t>
+              <a:t>Six demo PRs: which layer catches what</a:t>
             </a:r>
             <a:endParaRPr lang="en-US" sz="2600" dirty="0"/>
           </a:p>
@@ -6177,7 +6177,7 @@
                 <a:gridCol w="731520"/>
                 <a:gridCol w="3383280"/>
               </a:tblGrid>
-              <a:tr h="310896">
+              <a:tr h="292608">
                 <a:tc>
                   <a:txBody>
                     <a:bodyPr/>
@@ -6587,7 +6587,7 @@
                   </a:tcPr>
                 </a:tc>
               </a:tr>
-              <a:tr h="420624">
+              <a:tr h="384048">
                 <a:tc>
                   <a:txBody>
                     <a:bodyPr/>
@@ -6997,7 +6997,7 @@
                   </a:tcPr>
                 </a:tc>
               </a:tr>
-              <a:tr h="457200">
+              <a:tr h="420624">
                 <a:tc>
                   <a:txBody>
                     <a:bodyPr/>
@@ -7407,7 +7407,7 @@
                   </a:tcPr>
                 </a:tc>
               </a:tr>
-              <a:tr h="420624">
+              <a:tr h="384048">
                 <a:tc>
                   <a:txBody>
                     <a:bodyPr/>
@@ -7817,7 +7817,7 @@
                   </a:tcPr>
                 </a:tc>
               </a:tr>
-              <a:tr h="420624">
+              <a:tr h="384048">
                 <a:tc>
                   <a:txBody>
                     <a:bodyPr/>
@@ -8227,7 +8227,7 @@
                   </a:tcPr>
                 </a:tc>
               </a:tr>
-              <a:tr h="420624">
+              <a:tr h="384048">
                 <a:tc>
                   <a:txBody>
                     <a:bodyPr/>
@@ -8637,6 +8637,416 @@
                   </a:tcPr>
                 </a:tc>
               </a:tr>
+              <a:tr h="384048">
+                <a:tc>
+                  <a:txBody>
+                    <a:bodyPr/>
+                    <a:lstStyle/>
+                    <a:p>
+                      <a:pPr indent="0" marL="0">
+                        <a:buNone/>
+                      </a:pPr>
+                      <a:r>
+                        <a:rPr lang="en-US" sz="950" b="1" dirty="0">
+                          <a:solidFill>
+                            <a:srgbClr val="1F2937"/>
+                          </a:solidFill>
+                          <a:latin typeface="Calibri" pitchFamily="34" charset="0"/>
+                          <a:ea typeface="Calibri" pitchFamily="34" charset="-122"/>
+                          <a:cs typeface="Calibri" pitchFamily="34" charset="-120"/>
+                        </a:rPr>
+                        <a:t>#6</a:t>
+                      </a:r>
+                      <a:endParaRPr lang="en-US" sz="950" dirty="0">
+                        <a:latin typeface="Calibri" charset="0"/>
+                        <a:ea typeface="Calibri" charset="0"/>
+                        <a:cs typeface="Calibri" charset="0"/>
+                      </a:endParaRPr>
+                    </a:p>
+                  </a:txBody>
+                  <a:tcPr marL="91440" marR="91440" marT="45720" marB="45720" anchor="ctr">
+                    <a:lnL w="6350" cap="flat" cmpd="sng" algn="ctr">
+                      <a:solidFill>
+                        <a:srgbClr val="D5DCE5"/>
+                      </a:solidFill>
+                      <a:prstDash val="solid"/>
+                      <a:round/>
+                      <a:headEnd type="none" w="med" len="med"/>
+                      <a:tailEnd type="none" w="med" len="med"/>
+                    </a:lnL>
+                    <a:lnR w="6350" cap="flat" cmpd="sng" algn="ctr">
+                      <a:solidFill>
+                        <a:srgbClr val="D5DCE5"/>
+                      </a:solidFill>
+                      <a:prstDash val="solid"/>
+                      <a:round/>
+                      <a:headEnd type="none" w="med" len="med"/>
+                      <a:tailEnd type="none" w="med" len="med"/>
+                    </a:lnR>
+                    <a:lnT w="6350" cap="flat" cmpd="sng" algn="ctr">
+                      <a:solidFill>
+                        <a:srgbClr val="D5DCE5"/>
+                      </a:solidFill>
+                      <a:prstDash val="solid"/>
+                      <a:round/>
+                      <a:headEnd type="none" w="med" len="med"/>
+                      <a:tailEnd type="none" w="med" len="med"/>
+                    </a:lnT>
+                    <a:lnB w="6350" cap="flat" cmpd="sng" algn="ctr">
+                      <a:solidFill>
+                        <a:srgbClr val="D5DCE5"/>
+                      </a:solidFill>
+                      <a:prstDash val="solid"/>
+                      <a:round/>
+                      <a:headEnd type="none" w="med" len="med"/>
+                      <a:tailEnd type="none" w="med" len="med"/>
+                    </a:lnB>
+                    <a:solidFill>
+                      <a:srgbClr val="FFFFFF"/>
+                    </a:solidFill>
+                  </a:tcPr>
+                </a:tc>
+                <a:tc>
+                  <a:txBody>
+                    <a:bodyPr/>
+                    <a:lstStyle/>
+                    <a:p>
+                      <a:pPr indent="0" marL="0">
+                        <a:buNone/>
+                      </a:pPr>
+                      <a:r>
+                        <a:rPr lang="en-US" sz="950" dirty="0">
+                          <a:solidFill>
+                            <a:srgbClr val="1F2937"/>
+                          </a:solidFill>
+                          <a:latin typeface="Calibri" pitchFamily="34" charset="0"/>
+                          <a:ea typeface="Calibri" pitchFamily="34" charset="-122"/>
+                          <a:cs typeface="Calibri" pitchFamily="34" charset="-120"/>
+                        </a:rPr>
+                        <a:t>Android</a:t>
+                      </a:r>
+                      <a:endParaRPr lang="en-US" sz="950" dirty="0">
+                        <a:latin typeface="Calibri" charset="0"/>
+                        <a:ea typeface="Calibri" charset="0"/>
+                        <a:cs typeface="Calibri" charset="0"/>
+                      </a:endParaRPr>
+                    </a:p>
+                  </a:txBody>
+                  <a:tcPr marL="91440" marR="91440" marT="45720" marB="45720" anchor="ctr">
+                    <a:lnL w="6350" cap="flat" cmpd="sng" algn="ctr">
+                      <a:solidFill>
+                        <a:srgbClr val="D5DCE5"/>
+                      </a:solidFill>
+                      <a:prstDash val="solid"/>
+                      <a:round/>
+                      <a:headEnd type="none" w="med" len="med"/>
+                      <a:tailEnd type="none" w="med" len="med"/>
+                    </a:lnL>
+                    <a:lnR w="6350" cap="flat" cmpd="sng" algn="ctr">
+                      <a:solidFill>
+                        <a:srgbClr val="D5DCE5"/>
+                      </a:solidFill>
+                      <a:prstDash val="solid"/>
+                      <a:round/>
+                      <a:headEnd type="none" w="med" len="med"/>
+                      <a:tailEnd type="none" w="med" len="med"/>
+                    </a:lnR>
+                    <a:lnT w="6350" cap="flat" cmpd="sng" algn="ctr">
+                      <a:solidFill>
+                        <a:srgbClr val="D5DCE5"/>
+                      </a:solidFill>
+                      <a:prstDash val="solid"/>
+                      <a:round/>
+                      <a:headEnd type="none" w="med" len="med"/>
+                      <a:tailEnd type="none" w="med" len="med"/>
+                    </a:lnT>
+                    <a:lnB w="6350" cap="flat" cmpd="sng" algn="ctr">
+                      <a:solidFill>
+                        <a:srgbClr val="D5DCE5"/>
+                      </a:solidFill>
+                      <a:prstDash val="solid"/>
+                      <a:round/>
+                      <a:headEnd type="none" w="med" len="med"/>
+                      <a:tailEnd type="none" w="med" len="med"/>
+                    </a:lnB>
+                    <a:solidFill>
+                      <a:srgbClr val="FFFFFF"/>
+                    </a:solidFill>
+                  </a:tcPr>
+                </a:tc>
+                <a:tc>
+                  <a:txBody>
+                    <a:bodyPr/>
+                    <a:lstStyle/>
+                    <a:p>
+                      <a:pPr indent="0" marL="0">
+                        <a:buNone/>
+                      </a:pPr>
+                      <a:r>
+                        <a:rPr lang="en-US" sz="950" dirty="0">
+                          <a:solidFill>
+                            <a:srgbClr val="1F2937"/>
+                          </a:solidFill>
+                          <a:latin typeface="Calibri" pitchFamily="34" charset="0"/>
+                          <a:ea typeface="Calibri" pitchFamily="34" charset="-122"/>
+                          <a:cs typeface="Calibri" pitchFamily="34" charset="-120"/>
+                        </a:rPr>
+                        <a:t>test fails once, passes on retry</a:t>
+                      </a:r>
+                      <a:endParaRPr lang="en-US" sz="950" dirty="0">
+                        <a:latin typeface="Calibri" charset="0"/>
+                        <a:ea typeface="Calibri" charset="0"/>
+                        <a:cs typeface="Calibri" charset="0"/>
+                      </a:endParaRPr>
+                    </a:p>
+                  </a:txBody>
+                  <a:tcPr marL="91440" marR="91440" marT="45720" marB="45720" anchor="ctr">
+                    <a:lnL w="6350" cap="flat" cmpd="sng" algn="ctr">
+                      <a:solidFill>
+                        <a:srgbClr val="D5DCE5"/>
+                      </a:solidFill>
+                      <a:prstDash val="solid"/>
+                      <a:round/>
+                      <a:headEnd type="none" w="med" len="med"/>
+                      <a:tailEnd type="none" w="med" len="med"/>
+                    </a:lnL>
+                    <a:lnR w="6350" cap="flat" cmpd="sng" algn="ctr">
+                      <a:solidFill>
+                        <a:srgbClr val="D5DCE5"/>
+                      </a:solidFill>
+                      <a:prstDash val="solid"/>
+                      <a:round/>
+                      <a:headEnd type="none" w="med" len="med"/>
+                      <a:tailEnd type="none" w="med" len="med"/>
+                    </a:lnR>
+                    <a:lnT w="6350" cap="flat" cmpd="sng" algn="ctr">
+                      <a:solidFill>
+                        <a:srgbClr val="D5DCE5"/>
+                      </a:solidFill>
+                      <a:prstDash val="solid"/>
+                      <a:round/>
+                      <a:headEnd type="none" w="med" len="med"/>
+                      <a:tailEnd type="none" w="med" len="med"/>
+                    </a:lnT>
+                    <a:lnB w="6350" cap="flat" cmpd="sng" algn="ctr">
+                      <a:solidFill>
+                        <a:srgbClr val="D5DCE5"/>
+                      </a:solidFill>
+                      <a:prstDash val="solid"/>
+                      <a:round/>
+                      <a:headEnd type="none" w="med" len="med"/>
+                      <a:tailEnd type="none" w="med" len="med"/>
+                    </a:lnB>
+                    <a:solidFill>
+                      <a:srgbClr val="FFFFFF"/>
+                    </a:solidFill>
+                  </a:tcPr>
+                </a:tc>
+                <a:tc>
+                  <a:txBody>
+                    <a:bodyPr/>
+                    <a:lstStyle/>
+                    <a:p>
+                      <a:pPr algn="ctr" indent="0" marL="0">
+                        <a:buNone/>
+                      </a:pPr>
+                      <a:r>
+                        <a:rPr lang="en-US" sz="1000" b="1" dirty="0">
+                          <a:solidFill>
+                            <a:srgbClr val="2E9E5B"/>
+                          </a:solidFill>
+                          <a:latin typeface="Calibri" pitchFamily="34" charset="0"/>
+                          <a:ea typeface="Calibri" pitchFamily="34" charset="-122"/>
+                          <a:cs typeface="Calibri" pitchFamily="34" charset="-120"/>
+                        </a:rPr>
+                        <a:t>passes</a:t>
+                      </a:r>
+                      <a:endParaRPr lang="en-US" sz="1000" dirty="0">
+                        <a:latin typeface="Calibri" charset="0"/>
+                        <a:ea typeface="Calibri" charset="0"/>
+                        <a:cs typeface="Calibri" charset="0"/>
+                      </a:endParaRPr>
+                    </a:p>
+                  </a:txBody>
+                  <a:tcPr marL="91440" marR="91440" marT="45720" marB="45720" anchor="ctr">
+                    <a:lnL w="6350" cap="flat" cmpd="sng" algn="ctr">
+                      <a:solidFill>
+                        <a:srgbClr val="D5DCE5"/>
+                      </a:solidFill>
+                      <a:prstDash val="solid"/>
+                      <a:round/>
+                      <a:headEnd type="none" w="med" len="med"/>
+                      <a:tailEnd type="none" w="med" len="med"/>
+                    </a:lnL>
+                    <a:lnR w="6350" cap="flat" cmpd="sng" algn="ctr">
+                      <a:solidFill>
+                        <a:srgbClr val="D5DCE5"/>
+                      </a:solidFill>
+                      <a:prstDash val="solid"/>
+                      <a:round/>
+                      <a:headEnd type="none" w="med" len="med"/>
+                      <a:tailEnd type="none" w="med" len="med"/>
+                    </a:lnR>
+                    <a:lnT w="6350" cap="flat" cmpd="sng" algn="ctr">
+                      <a:solidFill>
+                        <a:srgbClr val="D5DCE5"/>
+                      </a:solidFill>
+                      <a:prstDash val="solid"/>
+                      <a:round/>
+                      <a:headEnd type="none" w="med" len="med"/>
+                      <a:tailEnd type="none" w="med" len="med"/>
+                    </a:lnT>
+                    <a:lnB w="6350" cap="flat" cmpd="sng" algn="ctr">
+                      <a:solidFill>
+                        <a:srgbClr val="D5DCE5"/>
+                      </a:solidFill>
+                      <a:prstDash val="solid"/>
+                      <a:round/>
+                      <a:headEnd type="none" w="med" len="med"/>
+                      <a:tailEnd type="none" w="med" len="med"/>
+                    </a:lnB>
+                    <a:solidFill>
+                      <a:srgbClr val="FFFFFF"/>
+                    </a:solidFill>
+                  </a:tcPr>
+                </a:tc>
+                <a:tc>
+                  <a:txBody>
+                    <a:bodyPr/>
+                    <a:lstStyle/>
+                    <a:p>
+                      <a:pPr algn="ctr" indent="0" marL="0">
+                        <a:buNone/>
+                      </a:pPr>
+                      <a:r>
+                        <a:rPr lang="en-US" sz="1000" b="1" dirty="0">
+                          <a:solidFill>
+                            <a:srgbClr val="2E9E5B"/>
+                          </a:solidFill>
+                          <a:latin typeface="Calibri" pitchFamily="34" charset="0"/>
+                          <a:ea typeface="Calibri" pitchFamily="34" charset="-122"/>
+                          <a:cs typeface="Calibri" pitchFamily="34" charset="-120"/>
+                        </a:rPr>
+                        <a:t>passes</a:t>
+                      </a:r>
+                      <a:endParaRPr lang="en-US" sz="1000" dirty="0">
+                        <a:latin typeface="Calibri" charset="0"/>
+                        <a:ea typeface="Calibri" charset="0"/>
+                        <a:cs typeface="Calibri" charset="0"/>
+                      </a:endParaRPr>
+                    </a:p>
+                  </a:txBody>
+                  <a:tcPr marL="91440" marR="91440" marT="45720" marB="45720" anchor="ctr">
+                    <a:lnL w="6350" cap="flat" cmpd="sng" algn="ctr">
+                      <a:solidFill>
+                        <a:srgbClr val="D5DCE5"/>
+                      </a:solidFill>
+                      <a:prstDash val="solid"/>
+                      <a:round/>
+                      <a:headEnd type="none" w="med" len="med"/>
+                      <a:tailEnd type="none" w="med" len="med"/>
+                    </a:lnL>
+                    <a:lnR w="6350" cap="flat" cmpd="sng" algn="ctr">
+                      <a:solidFill>
+                        <a:srgbClr val="D5DCE5"/>
+                      </a:solidFill>
+                      <a:prstDash val="solid"/>
+                      <a:round/>
+                      <a:headEnd type="none" w="med" len="med"/>
+                      <a:tailEnd type="none" w="med" len="med"/>
+                    </a:lnR>
+                    <a:lnT w="6350" cap="flat" cmpd="sng" algn="ctr">
+                      <a:solidFill>
+                        <a:srgbClr val="D5DCE5"/>
+                      </a:solidFill>
+                      <a:prstDash val="solid"/>
+                      <a:round/>
+                      <a:headEnd type="none" w="med" len="med"/>
+                      <a:tailEnd type="none" w="med" len="med"/>
+                    </a:lnT>
+                    <a:lnB w="6350" cap="flat" cmpd="sng" algn="ctr">
+                      <a:solidFill>
+                        <a:srgbClr val="D5DCE5"/>
+                      </a:solidFill>
+                      <a:prstDash val="solid"/>
+                      <a:round/>
+                      <a:headEnd type="none" w="med" len="med"/>
+                      <a:tailEnd type="none" w="med" len="med"/>
+                    </a:lnB>
+                    <a:solidFill>
+                      <a:srgbClr val="FFFFFF"/>
+                    </a:solidFill>
+                  </a:tcPr>
+                </a:tc>
+                <a:tc>
+                  <a:txBody>
+                    <a:bodyPr/>
+                    <a:lstStyle/>
+                    <a:p>
+                      <a:pPr indent="0" marL="0">
+                        <a:buNone/>
+                      </a:pPr>
+                      <a:r>
+                        <a:rPr lang="en-US" sz="950" dirty="0">
+                          <a:solidFill>
+                            <a:srgbClr val="1F2937"/>
+                          </a:solidFill>
+                          <a:latin typeface="Calibri" pitchFamily="34" charset="0"/>
+                          <a:ea typeface="Calibri" pitchFamily="34" charset="-122"/>
+                          <a:cs typeface="Calibri" pitchFamily="34" charset="-120"/>
+                        </a:rPr>
+                        <a:t>Green but flagged FLAKY: summary + PR comment</a:t>
+                      </a:r>
+                      <a:endParaRPr lang="en-US" sz="950" dirty="0">
+                        <a:latin typeface="Calibri" charset="0"/>
+                        <a:ea typeface="Calibri" charset="0"/>
+                        <a:cs typeface="Calibri" charset="0"/>
+                      </a:endParaRPr>
+                    </a:p>
+                  </a:txBody>
+                  <a:tcPr marL="91440" marR="91440" marT="45720" marB="45720" anchor="ctr">
+                    <a:lnL w="6350" cap="flat" cmpd="sng" algn="ctr">
+                      <a:solidFill>
+                        <a:srgbClr val="D5DCE5"/>
+                      </a:solidFill>
+                      <a:prstDash val="solid"/>
+                      <a:round/>
+                      <a:headEnd type="none" w="med" len="med"/>
+                      <a:tailEnd type="none" w="med" len="med"/>
+                    </a:lnL>
+                    <a:lnR w="6350" cap="flat" cmpd="sng" algn="ctr">
+                      <a:solidFill>
+                        <a:srgbClr val="D5DCE5"/>
+                      </a:solidFill>
+                      <a:prstDash val="solid"/>
+                      <a:round/>
+                      <a:headEnd type="none" w="med" len="med"/>
+                      <a:tailEnd type="none" w="med" len="med"/>
+                    </a:lnR>
+                    <a:lnT w="6350" cap="flat" cmpd="sng" algn="ctr">
+                      <a:solidFill>
+                        <a:srgbClr val="D5DCE5"/>
+                      </a:solidFill>
+                      <a:prstDash val="solid"/>
+                      <a:round/>
+                      <a:headEnd type="none" w="med" len="med"/>
+                      <a:tailEnd type="none" w="med" len="med"/>
+                    </a:lnT>
+                    <a:lnB w="6350" cap="flat" cmpd="sng" algn="ctr">
+                      <a:solidFill>
+                        <a:srgbClr val="D5DCE5"/>
+                      </a:solidFill>
+                      <a:prstDash val="solid"/>
+                      <a:round/>
+                      <a:headEnd type="none" w="med" len="med"/>
+                      <a:tailEnd type="none" w="med" len="med"/>
+                    </a:lnB>
+                    <a:solidFill>
+                      <a:srgbClr val="FFFFFF"/>
+                    </a:solidFill>
+                  </a:tcPr>
+                </a:tc>
+              </a:tr>
             </a:tbl>
           </a:graphicData>
         </a:graphic>
@@ -8649,12 +9059,12 @@
         </p:nvSpPr>
         <p:spPr>
           <a:xfrm>
-            <a:off x="457200" y="3703320"/>
-            <a:ext cx="4023360" cy="1005840"/>
+            <a:off x="457200" y="3840480"/>
+            <a:ext cx="4023360" cy="914400"/>
           </a:xfrm>
           <a:prstGeom prst="roundRect">
             <a:avLst>
-              <a:gd name="adj" fmla="val 7273"/>
+              <a:gd name="adj" fmla="val 8000"/>
             </a:avLst>
           </a:prstGeom>
           <a:solidFill>
@@ -8676,8 +9086,8 @@
         </p:nvSpPr>
         <p:spPr>
           <a:xfrm>
-            <a:off x="594360" y="3749040"/>
-            <a:ext cx="3749040" cy="914400"/>
+            <a:off x="594360" y="3858768"/>
+            <a:ext cx="3749040" cy="877824"/>
           </a:xfrm>
           <a:prstGeom prst="rect">
             <a:avLst/>
@@ -8729,12 +9139,12 @@
         </p:nvSpPr>
         <p:spPr>
           <a:xfrm>
-            <a:off x="4663440" y="3703320"/>
-            <a:ext cx="4023360" cy="1005840"/>
+            <a:off x="4663440" y="3840480"/>
+            <a:ext cx="4023360" cy="914400"/>
           </a:xfrm>
           <a:prstGeom prst="roundRect">
             <a:avLst>
-              <a:gd name="adj" fmla="val 7273"/>
+              <a:gd name="adj" fmla="val 8000"/>
             </a:avLst>
           </a:prstGeom>
           <a:solidFill>
@@ -8756,8 +9166,8 @@
         </p:nvSpPr>
         <p:spPr>
           <a:xfrm>
-            <a:off x="4800600" y="3749040"/>
-            <a:ext cx="3749040" cy="914400"/>
+            <a:off x="4800600" y="3858768"/>
+            <a:ext cx="3749040" cy="877824"/>
           </a:xfrm>
           <a:prstGeom prst="rect">
             <a:avLst/>

</xml_diff>

<commit_message>
Address audit: strict L2b without retries, non-JSON parity fix, honest docs, diagrams
Co-authored-by: Copilot App <223556219+Copilot@users.noreply.github.com>
</commit_message>
<xml_diff>
--- a/deliverables/SDK_QA_Strategy.pptx
+++ b/deliverables/SDK_QA_Strategy.pptx
@@ -861,7 +861,7 @@
           <a:p>
             <a:r>
               <a:rPr lang="en-US" dirty="0"/>
-              <a:t>Open PR #2 live: signature check green, behaviour check red on iOS only. Then PR #5 for the digester message, and PR #6 for the flaky flag.</a:t>
+              <a:t>Open PR #2 live: signature check green, behaviour check red on iOS only. Then PR #5 for the digester message, and PR #6: an intermittent test blocks the gate because L2b has no retries.</a:t>
             </a:r>
             <a:endParaRPr lang="en-US" dirty="0"/>
           </a:p>
@@ -5061,7 +5061,7 @@
                 <a:ea typeface="Calibri" pitchFamily="34" charset="-122"/>
                 <a:cs typeface="Calibri" pitchFamily="34" charset="-120"/>
               </a:rPr>
-              <a:t>10 scenarios per platform from one JSON, run against a scripted fake server. Includes single-flight concurrent refresh.</a:t>
+              <a:t>11 scenarios per platform from one JSON, run against a scripted fake server. Includes single-flight concurrent refresh.</a:t>
             </a:r>
             <a:endParaRPr lang="en-US" sz="1050" dirty="0"/>
           </a:p>
@@ -5781,7 +5781,7 @@
                 <a:ea typeface="Calibri" pitchFamily="34" charset="-122"/>
                 <a:cs typeface="Calibri" pitchFamily="34" charset="-120"/>
               </a:rPr>
-              <a:t>Retry once; a pass on retry is reported FLAKY, never silently green.</a:t>
+              <a:t>No retries in L2b (intermittent = bug). L3b and above: retry once, flag FLAKY, never silently green.</a:t>
             </a:r>
             <a:endParaRPr lang="en-US" sz="1050" dirty="0"/>
           </a:p>
@@ -8791,7 +8791,7 @@
                           <a:ea typeface="Calibri" pitchFamily="34" charset="-122"/>
                           <a:cs typeface="Calibri" pitchFamily="34" charset="-120"/>
                         </a:rPr>
-                        <a:t>test fails once, passes on retry</a:t>
+                        <a:t>test fails once, then passes</a:t>
                       </a:r>
                       <a:endParaRPr lang="en-US" sz="950" dirty="0">
                         <a:latin typeface="Calibri" charset="0"/>
@@ -8921,13 +8921,13 @@
                       <a:r>
                         <a:rPr lang="en-US" sz="1000" b="1" dirty="0">
                           <a:solidFill>
-                            <a:srgbClr val="2E9E5B"/>
+                            <a:srgbClr val="E5484D"/>
                           </a:solidFill>
                           <a:latin typeface="Calibri" pitchFamily="34" charset="0"/>
                           <a:ea typeface="Calibri" pitchFamily="34" charset="-122"/>
                           <a:cs typeface="Calibri" pitchFamily="34" charset="-120"/>
                         </a:rPr>
-                        <a:t>passes</a:t>
+                        <a:t>fails</a:t>
                       </a:r>
                       <a:endParaRPr lang="en-US" sz="1000" dirty="0">
                         <a:latin typeface="Calibri" charset="0"/>
@@ -8995,7 +8995,7 @@
                           <a:ea typeface="Calibri" pitchFamily="34" charset="-122"/>
                           <a:cs typeface="Calibri" pitchFamily="34" charset="-120"/>
                         </a:rPr>
-                        <a:t>Green but flagged FLAKY: summary + PR comment</a:t>
+                        <a:t>Intermittent test blocks: no retries in L2b</a:t>
                       </a:r>
                       <a:endParaRPr lang="en-US" sz="950" dirty="0">
                         <a:latin typeface="Calibri" charset="0"/>

</xml_diff>

<commit_message>
Audit round 2: AI disclosure, counts, connected diagrams, non-empty scenario guard
Co-authored-by: Copilot App <223556219+Copilot@users.noreply.github.com>
</commit_message>
<xml_diff>
--- a/deliverables/SDK_QA_Strategy.pptx
+++ b/deliverables/SDK_QA_Strategy.pptx
@@ -2063,7 +2063,7 @@
                 <a:ea typeface="Cambria" pitchFamily="34" charset="-122"/>
                 <a:cs typeface="Cambria" pitchFamily="34" charset="-120"/>
               </a:rPr>
-              <a:t>10</a:t>
+              <a:t>11</a:t>
             </a:r>
             <a:endParaRPr lang="en-US" sz="3600" dirty="0"/>
           </a:p>
@@ -5061,7 +5061,7 @@
                 <a:ea typeface="Calibri" pitchFamily="34" charset="-122"/>
                 <a:cs typeface="Calibri" pitchFamily="34" charset="-120"/>
               </a:rPr>
-              <a:t>11 scenarios per platform from one JSON, run against a scripted fake server. Includes single-flight concurrent refresh.</a:t>
+              <a:t>11 scenarios per platform (core JSON plus consumer-owned files), run against a scripted fake server. Includes single-flight concurrent refresh.</a:t>
             </a:r>
             <a:endParaRPr lang="en-US" sz="1050" dirty="0"/>
           </a:p>
@@ -5493,7 +5493,7 @@
                 <a:ea typeface="Calibri" pitchFamily="34" charset="-122"/>
                 <a:cs typeface="Calibri" pitchFamily="34" charset="-120"/>
               </a:rPr>
-              <a:t>4 Espresso + 4 XCUITest tests: sign-in, error, background, kill and relaunch.</a:t>
+              <a:t>4 Espresso + 4 XCUITest tests. Both: sign-in and error. Android: recreation and simulated cold start. iOS: background, and terminate and relaunch (Keychain).</a:t>
             </a:r>
             <a:endParaRPr lang="en-US" sz="1050" dirty="0"/>
           </a:p>

</xml_diff>

<commit_message>
Questions for the team as table Q1-Q16 linked to assumptions; deck slide 8 open-questions line
Co-authored-by: Copilot App <223556219+Copilot@users.noreply.github.com>
</commit_message>
<xml_diff>
--- a/deliverables/SDK_QA_Strategy.pptx
+++ b/deliverables/SDK_QA_Strategy.pptx
@@ -13667,6 +13667,59 @@
           </a:p>
         </p:txBody>
       </p:sp>
+      <p:sp>
+        <p:nvSpPr>
+          <p:cNvPr id="26" name="Text 24"/>
+          <p:cNvSpPr/>
+          <p:nvPr/>
+        </p:nvSpPr>
+        <p:spPr>
+          <a:xfrm>
+            <a:off x="457200" y="4434840"/>
+            <a:ext cx="7772400" cy="274320"/>
+          </a:xfrm>
+          <a:prstGeom prst="rect">
+            <a:avLst/>
+          </a:prstGeom>
+          <a:noFill/>
+          <a:ln/>
+        </p:spPr>
+        <p:txBody>
+          <a:bodyPr wrap="square" lIns="0" tIns="0" rIns="0" bIns="0" rtlCol="0" anchor="ctr"/>
+          <a:lstStyle/>
+          <a:p>
+            <a:pPr indent="0" marL="0">
+              <a:buNone/>
+            </a:pPr>
+            <a:r>
+              <a:rPr lang="en-US" sz="1000" b="1" dirty="0">
+                <a:solidFill>
+                  <a:srgbClr val="F2A541"/>
+                </a:solidFill>
+                <a:latin typeface="Calibri" pitchFamily="34" charset="0"/>
+                <a:ea typeface="Calibri" pitchFamily="34" charset="-122"/>
+                <a:cs typeface="Calibri" pitchFamily="34" charset="-120"/>
+              </a:rPr>
+              <a:t>Questions that change these priorities (document §5.1): </a:t>
+            </a:r>
+            <a:pPr indent="0" marL="0">
+              <a:buNone/>
+            </a:pPr>
+            <a:r>
+              <a:rPr lang="en-US" sz="1000" dirty="0">
+                <a:solidFill>
+                  <a:srgbClr val="E6EDF7"/>
+                </a:solidFill>
+                <a:latin typeface="Calibri" pitchFamily="34" charset="0"/>
+                <a:ea typeface="Calibri" pitchFamily="34" charset="-122"/>
+                <a:cs typeface="Calibri" pitchFamily="34" charset="-120"/>
+              </a:rPr>
+              <a:t>shared code between platforms? does the SDK ship UI? what was the last escaped defect?</a:t>
+            </a:r>
+            <a:endParaRPr lang="en-US" sz="1000" dirty="0"/>
+          </a:p>
+        </p:txBody>
+      </p:sp>
     </p:spTree>
   </p:cSld>
   <p:clrMapOvr>

</xml_diff>

<commit_message>
Deck: add non-JSON 200 finding (slide 4); mark unbuilt CI/CD boxes as dashed (slide 6)
Co-authored-by: Copilot App <223556219+Copilot@users.noreply.github.com>
</commit_message>
<xml_diff>
--- a/deliverables/SDK_QA_Strategy.pptx
+++ b/deliverables/SDK_QA_Strategy.pptx
@@ -5882,7 +5882,7 @@
               <a:buChar char="•"/>
             </a:pPr>
             <a:r>
-              <a:rPr lang="en-US" sz="1150" dirty="0">
+              <a:rPr lang="en-US" sz="1050" dirty="0">
                 <a:solidFill>
                   <a:srgbClr val="E6EDF7"/>
                 </a:solidFill>
@@ -5892,7 +5892,7 @@
               </a:rPr>
               <a:t>Concurrent refresh failed on both platforms (duplicate refreshes). Fixed with an in-flight task and a lock.</a:t>
             </a:r>
-            <a:endParaRPr lang="en-US" sz="1150" dirty="0"/>
+            <a:endParaRPr lang="en-US" sz="1050" dirty="0"/>
           </a:p>
           <a:p>
             <a:pPr marL="342900" indent="-342900">
@@ -5903,7 +5903,7 @@
               <a:buChar char="•"/>
             </a:pPr>
             <a:r>
-              <a:rPr lang="en-US" sz="1150" dirty="0">
+              <a:rPr lang="en-US" sz="1050" dirty="0">
                 <a:solidFill>
                   <a:srgbClr val="E6EDF7"/>
                 </a:solidFill>
@@ -5913,7 +5913,7 @@
               </a:rPr>
               <a:t>Malformed body leaked a JSONException on Android only. Mapped to serverError.</a:t>
             </a:r>
-            <a:endParaRPr lang="en-US" sz="1150" dirty="0"/>
+            <a:endParaRPr lang="en-US" sz="1050" dirty="0"/>
           </a:p>
           <a:p>
             <a:pPr marL="342900" indent="-342900">
@@ -5924,7 +5924,7 @@
               <a:buChar char="•"/>
             </a:pPr>
             <a:r>
-              <a:rPr lang="en-US" sz="1150" dirty="0">
+              <a:rPr lang="en-US" sz="1050" dirty="0">
                 <a:solidFill>
                   <a:srgbClr val="E6EDF7"/>
                 </a:solidFill>
@@ -5932,9 +5932,9 @@
                 <a:ea typeface="Calibri" pitchFamily="34" charset="-122"/>
                 <a:cs typeface="Calibri" pitchFamily="34" charset="-120"/>
               </a:rPr>
-              <a:t>Injected iOS-only bug (503 as session expiry) caught by a scenario.</a:t>
-            </a:r>
-            <a:endParaRPr lang="en-US" sz="1150" dirty="0"/>
+              <a:t>Non-JSON 200 body escaped on iOS only; Kotlin already mapped it. Fixed in Swift: the iOS/Android inconsistency the brief warns about.</a:t>
+            </a:r>
+            <a:endParaRPr lang="en-US" sz="1050" dirty="0"/>
           </a:p>
           <a:p>
             <a:pPr marL="342900" indent="-342900">
@@ -5945,7 +5945,7 @@
               <a:buChar char="•"/>
             </a:pPr>
             <a:r>
-              <a:rPr lang="en-US" sz="1150" dirty="0">
+              <a:rPr lang="en-US" sz="1050" dirty="0">
                 <a:solidFill>
                   <a:srgbClr val="E6EDF7"/>
                 </a:solidFill>
@@ -5953,9 +5953,30 @@
                 <a:ea typeface="Calibri" pitchFamily="34" charset="-122"/>
                 <a:cs typeface="Calibri" pitchFamily="34" charset="-120"/>
               </a:rPr>
+              <a:t>Injected iOS-only bug (503 as session expiry) caught by a scenario.</a:t>
+            </a:r>
+            <a:endParaRPr lang="en-US" sz="1050" dirty="0"/>
+          </a:p>
+          <a:p>
+            <a:pPr marL="342900" indent="-342900">
+              <a:spcAft>
+                <a:spcPts val="300"/>
+              </a:spcAft>
+              <a:buSzPct val="100000"/>
+              <a:buChar char="•"/>
+            </a:pPr>
+            <a:r>
+              <a:rPr lang="en-US" sz="1050" dirty="0">
+                <a:solidFill>
+                  <a:srgbClr val="E6EDF7"/>
+                </a:solidFill>
+                <a:latin typeface="Calibri" pitchFamily="34" charset="0"/>
+                <a:ea typeface="Calibri" pitchFamily="34" charset="-122"/>
+                <a:cs typeface="Calibri" pitchFamily="34" charset="-120"/>
+              </a:rPr>
               <a:t>Swapping Keychain for memory made the relaunch test fail, so it is sensitive.</a:t>
             </a:r>
-            <a:endParaRPr lang="en-US" sz="1150" dirty="0"/>
+            <a:endParaRPr lang="en-US" sz="1050" dirty="0"/>
           </a:p>
         </p:txBody>
       </p:sp>
@@ -9875,13 +9896,13 @@
             </a:avLst>
           </a:prstGeom>
           <a:solidFill>
-            <a:srgbClr val="0B1F3A"/>
+            <a:srgbClr val="FFFFFF"/>
           </a:solidFill>
           <a:ln w="15875">
             <a:solidFill>
-              <a:srgbClr val="0B1F3A"/>
+              <a:srgbClr val="5B6675"/>
             </a:solidFill>
-            <a:prstDash val="solid"/>
+            <a:prstDash val="dash"/>
           </a:ln>
         </p:spPr>
       </p:sp>
@@ -9912,7 +9933,7 @@
             <a:r>
               <a:rPr lang="en-US" sz="1050" b="1" dirty="0">
                 <a:solidFill>
-                  <a:srgbClr val="FFFFFF"/>
+                  <a:srgbClr val="5B6675"/>
                 </a:solidFill>
                 <a:latin typeface="Calibri" pitchFamily="34" charset="0"/>
                 <a:ea typeface="Calibri" pitchFamily="34" charset="-122"/>
@@ -9929,13 +9950,13 @@
             <a:r>
               <a:rPr lang="en-US" sz="850" dirty="0">
                 <a:solidFill>
-                  <a:srgbClr val="FFFFFF"/>
-                </a:solidFill>
-                <a:latin typeface="Calibri" pitchFamily="34" charset="0"/>
-                <a:ea typeface="Calibri" pitchFamily="34" charset="-122"/>
-                <a:cs typeface="Calibri" pitchFamily="34" charset="-120"/>
-              </a:rPr>
-              <a:t>owner-routed failures</a:t>
+                  <a:srgbClr val="5B6675"/>
+                </a:solidFill>
+                <a:latin typeface="Calibri" pitchFamily="34" charset="0"/>
+                <a:ea typeface="Calibri" pitchFamily="34" charset="-122"/>
+                <a:cs typeface="Calibri" pitchFamily="34" charset="-120"/>
+              </a:rPr>
+              <a:t>owner-routed failures (planned)</a:t>
             </a:r>
             <a:endParaRPr lang="en-US" sz="1050" dirty="0"/>
           </a:p>
@@ -10526,13 +10547,13 @@
             </a:avLst>
           </a:prstGeom>
           <a:solidFill>
-            <a:srgbClr val="0B1F3A"/>
+            <a:srgbClr val="FFFFFF"/>
           </a:solidFill>
           <a:ln w="15875">
             <a:solidFill>
-              <a:srgbClr val="0B1F3A"/>
+              <a:srgbClr val="5B6675"/>
             </a:solidFill>
-            <a:prstDash val="solid"/>
+            <a:prstDash val="dash"/>
           </a:ln>
         </p:spPr>
       </p:sp>
@@ -10563,7 +10584,7 @@
             <a:r>
               <a:rPr lang="en-US" sz="1050" b="1" dirty="0">
                 <a:solidFill>
-                  <a:srgbClr val="FFFFFF"/>
+                  <a:srgbClr val="5B6675"/>
                 </a:solidFill>
                 <a:latin typeface="Calibri" pitchFamily="34" charset="0"/>
                 <a:ea typeface="Calibri" pitchFamily="34" charset="-122"/>
@@ -10592,13 +10613,13 @@
             </a:avLst>
           </a:prstGeom>
           <a:solidFill>
-            <a:srgbClr val="13A89E"/>
+            <a:srgbClr val="FFFFFF"/>
           </a:solidFill>
           <a:ln w="15875">
             <a:solidFill>
-              <a:srgbClr val="13A89E"/>
+              <a:srgbClr val="5B6675"/>
             </a:solidFill>
-            <a:prstDash val="solid"/>
+            <a:prstDash val="dash"/>
           </a:ln>
         </p:spPr>
       </p:sp>
@@ -10629,7 +10650,7 @@
             <a:r>
               <a:rPr lang="en-US" sz="1050" b="1" dirty="0">
                 <a:solidFill>
-                  <a:srgbClr val="FFFFFF"/>
+                  <a:srgbClr val="5B6675"/>
                 </a:solidFill>
                 <a:latin typeface="Calibri" pitchFamily="34" charset="0"/>
                 <a:ea typeface="Calibri" pitchFamily="34" charset="-122"/>

</xml_diff>